<commit_message>
Pose models, ONNX device selection, Argus report and docs reorganisation
Co-Authored-By: Claude Opus 5.5 <noreply@anthropic.com>
</commit_message>
<xml_diff>
--- a/docs/argus/Argus.pptx
+++ b/docs/argus/Argus.pptx
@@ -14,6 +14,7 @@
     <p:sldId id="262" r:id="rId8"/>
     <p:sldId id="263" r:id="rId9"/>
     <p:sldId id="264" r:id="rId10"/>
+    <p:sldId id="270" r:id="rId21"/>
     <p:sldId id="265" r:id="rId11"/>
     <p:sldId id="266" r:id="rId12"/>
     <p:sldId id="267" r:id="rId13"/>
@@ -1036,6 +1037,76 @@
 </p:notes>
 </file>
 
+<file path=ppt/notesSlides/notesSlide15.xml><?xml version="1.0" encoding="utf-8"?>
+<p:notes xmlns:a="http://schemas.openxmlformats.org/drawingml/2006/main" xmlns:p="http://schemas.openxmlformats.org/presentationml/2006/main" xmlns:r="http://schemas.openxmlformats.org/officeDocument/2006/relationships">
+  <p:cSld>
+    <p:spTree>
+      <p:nvGrpSpPr>
+        <p:cNvPr id="1" name=""/>
+        <p:cNvGrpSpPr/>
+        <p:nvPr/>
+      </p:nvGrpSpPr>
+      <p:grpSpPr>
+        <a:xfrm>
+          <a:off x="0" y="0"/>
+          <a:ext cx="0" cy="0"/>
+          <a:chOff x="0" y="0"/>
+          <a:chExt cx="0" cy="0"/>
+        </a:xfrm>
+      </p:grpSpPr>
+      <p:sp>
+        <p:nvSpPr>
+          <p:cNvPr id="2" name="Slide Image Placeholder 1"/>
+          <p:cNvSpPr>
+            <a:spLocks noGrp="1"/>
+          </p:cNvSpPr>
+          <p:nvPr>
+            <p:ph type="sldImg" idx="2"/>
+          </p:nvPr>
+        </p:nvSpPr>
+        <p:spPr/>
+      </p:sp>
+      <p:sp>
+        <p:nvSpPr>
+          <p:cNvPr id="3" name="Notes Placeholder 2"/>
+          <p:cNvSpPr>
+            <a:spLocks noGrp="1"/>
+          </p:cNvSpPr>
+          <p:nvPr>
+            <p:ph type="body" idx="3" sz="quarter"/>
+          </p:nvPr>
+        </p:nvSpPr>
+        <p:spPr/>
+        <p:txBody>
+          <a:bodyPr/>
+          <a:lstStyle/>
+          <a:p>
+            <a:r>
+              <a:t>New since October 2026: body poses. About once a second, each tracked person's crop goes through a pose model (ViTPose-B: Apache-2.0, trained on COCO only) that finds 17 body points. Simple rules turn them into facts: posture (standing, sitting, crouching, lying), hands above the head, facing the camera, and the colour of the top and trousers from the clothes the body outlines. A row is stored only when something changes, plus every 10 s, so the chat gets exact seconds per posture. Person-down (lying 10 s) and hands-up (3 s) events go through the same alert channels. Honest limits: people must be at least 80 px tall; colours disappear at night (infrared); sitting and crouching can be confused; person-down has been checked with tests and sample footage, not yet on staged falls, so we validate it on site before it goes live. Pose costs about 0.1 s per person on a laptop CPU. Keypoints are not a face print, but they follow the same retention as the rest.</a:t>
+            </a:r>
+          </a:p>
+        </p:txBody>
+      </p:sp>
+      <p:sp>
+        <p:nvSpPr>
+          <p:cNvPr id="4" name="Slide Number Placeholder 3"/>
+          <p:cNvSpPr>
+            <a:spLocks noGrp="1"/>
+          </p:cNvSpPr>
+          <p:nvPr>
+            <p:ph type="sldNum" idx="5" sz="quarter"/>
+          </p:nvPr>
+        </p:nvSpPr>
+        <p:spPr/>
+      </p:sp>
+    </p:spTree>
+  </p:cSld>
+  <p:clrMapOvr>
+    <a:masterClrMapping/>
+  </p:clrMapOvr>
+</p:notes>
+</file>
+
 <file path=ppt/notesSlides/notesSlide2.xml><?xml version="1.0" encoding="utf-8"?>
 <p:notes xmlns:a="http://schemas.openxmlformats.org/drawingml/2006/main" xmlns:r="http://schemas.openxmlformats.org/officeDocument/2006/relationships" xmlns:p="http://schemas.openxmlformats.org/presentationml/2006/main">
   <p:cSld>
@@ -1434,7 +1505,7 @@
           <a:p>
             <a:r>
               <a:rPr lang="en-US" dirty="0"/>
-              <a:t>Record: one recorder per camera detects and tracks every object (all 80 COCO classes), embeds each tracked object with CLIP, and every few seconds embeds the whole frame plus a 2x2 grid of tiles. Everything lands in one store per site. Ask: the question is parsed into what / when / which camera; the "what" is embedded with CLIP's text model and compared with stored vectors. Answer: an LLM gets the store as two tools and composes the answer with evidence thumbnails.</a:t>
+              <a:t>Record: one recorder per camera detects and tracks every object (all 80 COCO classes), embeds each tracked object with CLIP, and every few seconds embeds the whole frame plus a 2x2 grid of tiles. Everything lands in one store per site. Ask: the question is parsed into what / when / which camera; the "what" is embedded with CLIP's text model and compared with stored vectors. Answer: an LLM gets the store as tools (objects, search, alerts, people by pose and colour, and faces when approved) and composes the answer with evidence thumbnails.</a:t>
             </a:r>
             <a:endParaRPr lang="en-US" dirty="0"/>
           </a:p>
@@ -1610,7 +1681,7 @@
           <a:p>
             <a:r>
               <a:rPr lang="en-US" dirty="0"/>
-              <a:t>The language model has two lookups. "objects" returns tracked objects by time, class and co-occurrence: exact, no guessing. "search" is CLIP visual similarity for descriptions: ranked guesses where low-ranked hits can be wrong. The model never sees the database, only the results, and the thumbnails it was shown are returned as evidence. Counts are visits, not unique people: someone who leaves and comes back is two visits. Telling people apart across visits would need face recognition, which stays off unless approved.</a:t>
+              <a:t>The language model has a few lookups; the two main ones are these. "objects" returns tracked objects by time, class and co-occurrence: exact, no guessing. "search" is CLIP visual similarity for descriptions: ranked guesses where low-ranked hits can be wrong. Body poses add a third kind, measured: posture and clothing colour per person (see the next slides). The model never sees the database, only the results, and the thumbnails it was shown are returned as evidence. Counts are visits, not unique people: someone who leaves and comes back is two visits. Telling people apart across visits would need face recognition, which stays off unless approved.</a:t>
             </a:r>
             <a:endParaRPr lang="en-US" dirty="0"/>
           </a:p>
@@ -3444,6 +3515,625 @@
 
 <file path=ppt/slides/slide10.xml><?xml version="1.0" encoding="utf-8"?>
 <p:sld xmlns:a="http://schemas.openxmlformats.org/drawingml/2006/main" xmlns:r="http://schemas.openxmlformats.org/officeDocument/2006/relationships" xmlns:p="http://schemas.openxmlformats.org/presentationml/2006/main">
+  <p:cSld name="Slide 9">
+    <p:spTree>
+      <p:nvGrpSpPr>
+        <p:cNvPr id="1" name=""/>
+        <p:cNvGrpSpPr/>
+        <p:nvPr/>
+      </p:nvGrpSpPr>
+      <p:grpSpPr>
+        <a:xfrm>
+          <a:off x="0" y="0"/>
+          <a:ext cx="0" cy="0"/>
+          <a:chOff x="0" y="0"/>
+          <a:chExt cx="0" cy="0"/>
+        </a:xfrm>
+      </p:grpSpPr>
+      <p:sp>
+        <p:nvSpPr>
+          <p:cNvPr id="2" name="Text 1"/>
+          <p:cNvSpPr/>
+          <p:nvPr>
+            <p:ph idx="102" type="body" hasCustomPrompt="1"/>
+          </p:nvPr>
+        </p:nvSpPr>
+        <p:spPr>
+          <a:xfrm>
+            <a:off x="812800" y="812800"/>
+            <a:ext cx="10566400" cy="254000"/>
+          </a:xfrm>
+          <a:prstGeom prst="rect">
+            <a:avLst/>
+          </a:prstGeom>
+          <a:noFill/>
+          <a:ln/>
+        </p:spPr>
+        <p:txBody>
+          <a:bodyPr wrap="square" lIns="0" tIns="0" rIns="0" bIns="0" rtlCol="0" anchor="t"/>
+          <a:lstStyle/>
+          <a:p>
+            <a:pPr algn="l" indent="0" marL="0">
+              <a:buNone/>
+            </a:pPr>
+            <a:r>
+              <a:rPr lang="en-US" sz="1200" spc="300" kern="0" dirty="0">
+                <a:solidFill>
+                  <a:schemeClr val="accent2"/>
+                </a:solidFill>
+                <a:latin typeface="Consolas" pitchFamily="34" charset="0"/>
+                <a:ea typeface="Consolas" pitchFamily="34" charset="-122"/>
+                <a:cs typeface="Consolas" pitchFamily="34" charset="-120"/>
+              </a:rPr>
+              <a:t>// WHAT PEOPLE WERE DOING</a:t>
+            </a:r>
+            <a:endParaRPr lang="en-US" sz="1200" dirty="0"/>
+          </a:p>
+        </p:txBody>
+      </p:sp>
+      <p:sp>
+        <p:nvSpPr>
+          <p:cNvPr id="3" name="Text 1"/>
+          <p:cNvSpPr/>
+          <p:nvPr>
+            <p:ph idx="103" type="title" hasCustomPrompt="1"/>
+          </p:nvPr>
+        </p:nvSpPr>
+        <p:spPr>
+          <a:xfrm>
+            <a:off x="812800" y="1117600"/>
+            <a:ext cx="10566400" cy="1651000"/>
+          </a:xfrm>
+          <a:prstGeom prst="rect">
+            <a:avLst/>
+          </a:prstGeom>
+          <a:noFill/>
+          <a:ln/>
+        </p:spPr>
+        <p:txBody>
+          <a:bodyPr wrap="square" lIns="0" tIns="0" rIns="0" bIns="0" rtlCol="0" anchor="t"/>
+          <a:lstStyle/>
+          <a:p>
+            <a:pPr algn="l" indent="0" marL="0">
+              <a:lnSpc>
+                <a:spcPct val="95000"/>
+              </a:lnSpc>
+              <a:buNone/>
+            </a:pPr>
+            <a:r>
+              <a:rPr lang="en-US" sz="3600" b="1" dirty="0">
+                <a:solidFill>
+                  <a:schemeClr val="bg1"/>
+                </a:solidFill>
+                <a:latin typeface="Arial" pitchFamily="34" charset="0"/>
+                <a:ea typeface="Arial" pitchFamily="34" charset="-122"/>
+                <a:cs typeface="Arial" pitchFamily="34" charset="-120"/>
+              </a:rPr>
+              <a:t>Measured from the body, not guessed.</a:t>
+            </a:r>
+            <a:endParaRPr lang="en-US" sz="3600" dirty="0"/>
+          </a:p>
+        </p:txBody>
+      </p:sp>
+      <p:sp>
+        <p:nvSpPr>
+          <p:cNvPr id="5" name="pose-card-01"/>
+          <p:cNvSpPr/>
+          <p:nvPr/>
+        </p:nvSpPr>
+        <p:spPr>
+          <a:xfrm>
+            <a:off x="812800" y="2095500"/>
+            <a:ext cx="3384550" cy="2794000"/>
+          </a:xfrm>
+          <a:prstGeom prst="roundRect">
+            <a:avLst>
+              <a:gd name="adj" fmla="val 4545"/>
+            </a:avLst>
+          </a:prstGeom>
+          <a:solidFill>
+            <a:schemeClr val="accent4"/>
+          </a:solidFill>
+          <a:ln w="9525">
+            <a:solidFill>
+              <a:schemeClr val="accent5"/>
+            </a:solidFill>
+            <a:prstDash val="solid"/>
+          </a:ln>
+        </p:spPr>
+      </p:sp>
+      <p:sp>
+        <p:nvSpPr>
+          <p:cNvPr id="6" name="Text 3"/>
+          <p:cNvSpPr txBox="1"/>
+          <p:nvPr/>
+        </p:nvSpPr>
+        <p:spPr>
+          <a:xfrm>
+            <a:off x="1092200" y="2374900"/>
+            <a:ext cx="2825750" cy="215900"/>
+          </a:xfrm>
+          <a:prstGeom prst="rect">
+            <a:avLst/>
+          </a:prstGeom>
+          <a:noFill/>
+          <a:ln/>
+        </p:spPr>
+        <p:txBody>
+          <a:bodyPr wrap="square" lIns="0" tIns="0" rIns="0" bIns="0" rtlCol="0" anchor="t"/>
+          <a:lstStyle/>
+          <a:p>
+            <a:pPr indent="0" marL="0">
+              <a:buNone/>
+            </a:pPr>
+            <a:r>
+              <a:rPr lang="en-US" sz="1200" spc="100" kern="0" dirty="0">
+                <a:solidFill>
+                  <a:schemeClr val="accent2"/>
+                </a:solidFill>
+                <a:latin typeface="Consolas" pitchFamily="34" charset="0"/>
+                <a:ea typeface="Consolas" pitchFamily="34" charset="-122"/>
+                <a:cs typeface="Consolas" pitchFamily="34" charset="-120"/>
+              </a:rPr>
+              <a:t>01</a:t>
+            </a:r>
+            <a:endParaRPr lang="en-US" sz="1200" dirty="0"/>
+          </a:p>
+        </p:txBody>
+      </p:sp>
+      <p:sp>
+        <p:nvSpPr>
+          <p:cNvPr id="7" name="Text 4"/>
+          <p:cNvSpPr txBox="1"/>
+          <p:nvPr/>
+        </p:nvSpPr>
+        <p:spPr>
+          <a:xfrm>
+            <a:off x="1092200" y="2679700"/>
+            <a:ext cx="2825750" cy="698500"/>
+          </a:xfrm>
+          <a:prstGeom prst="rect">
+            <a:avLst/>
+          </a:prstGeom>
+          <a:noFill/>
+          <a:ln/>
+        </p:spPr>
+        <p:txBody>
+          <a:bodyPr wrap="square" lIns="0" tIns="0" rIns="0" bIns="0" rtlCol="0" anchor="t"/>
+          <a:lstStyle/>
+          <a:p>
+            <a:pPr indent="0" marL="0">
+              <a:buNone/>
+            </a:pPr>
+            <a:r>
+              <a:rPr lang="en-US" sz="2000" b="1" dirty="0">
+                <a:solidFill>
+                  <a:schemeClr val="bg1"/>
+                </a:solidFill>
+              </a:rPr>
+              <a:t>Posture</a:t>
+            </a:r>
+            <a:endParaRPr lang="en-US" sz="2000" dirty="0"/>
+          </a:p>
+        </p:txBody>
+      </p:sp>
+      <p:sp>
+        <p:nvSpPr>
+          <p:cNvPr id="8" name="Text 5"/>
+          <p:cNvSpPr txBox="1"/>
+          <p:nvPr/>
+        </p:nvSpPr>
+        <p:spPr>
+          <a:xfrm>
+            <a:off x="1092200" y="3467100"/>
+            <a:ext cx="2825750" cy="1333500"/>
+          </a:xfrm>
+          <a:prstGeom prst="rect">
+            <a:avLst/>
+          </a:prstGeom>
+          <a:noFill/>
+          <a:ln/>
+        </p:spPr>
+        <p:txBody>
+          <a:bodyPr wrap="square" lIns="0" tIns="0" rIns="0" bIns="0" rtlCol="0" anchor="t"/>
+          <a:lstStyle/>
+          <a:p>
+            <a:pPr indent="0" marL="0">
+              <a:buNone/>
+            </a:pPr>
+            <a:r>
+              <a:rPr lang="en-US" sz="1400" dirty="0">
+                <a:solidFill>
+                  <a:schemeClr val="bg2"/>
+                </a:solidFill>
+              </a:rPr>
+              <a:t>Standing, sitting, crouching or lying, with the seconds spent in each. "Did anyone fall in the warehouse last night?"</a:t>
+            </a:r>
+            <a:endParaRPr lang="en-US" sz="1400" dirty="0"/>
+          </a:p>
+        </p:txBody>
+      </p:sp>
+      <p:sp>
+        <p:nvSpPr>
+          <p:cNvPr id="9" name="pose-card-02"/>
+          <p:cNvSpPr/>
+          <p:nvPr/>
+        </p:nvSpPr>
+        <p:spPr>
+          <a:xfrm>
+            <a:off x="4400550" y="2095500"/>
+            <a:ext cx="3384550" cy="2794000"/>
+          </a:xfrm>
+          <a:prstGeom prst="roundRect">
+            <a:avLst>
+              <a:gd name="adj" fmla="val 4545"/>
+            </a:avLst>
+          </a:prstGeom>
+          <a:solidFill>
+            <a:schemeClr val="accent4"/>
+          </a:solidFill>
+          <a:ln w="9525">
+            <a:solidFill>
+              <a:schemeClr val="accent5"/>
+            </a:solidFill>
+            <a:prstDash val="solid"/>
+          </a:ln>
+        </p:spPr>
+      </p:sp>
+      <p:sp>
+        <p:nvSpPr>
+          <p:cNvPr id="10" name="Text 7"/>
+          <p:cNvSpPr txBox="1"/>
+          <p:nvPr/>
+        </p:nvSpPr>
+        <p:spPr>
+          <a:xfrm>
+            <a:off x="4679950" y="2374900"/>
+            <a:ext cx="2825750" cy="215900"/>
+          </a:xfrm>
+          <a:prstGeom prst="rect">
+            <a:avLst/>
+          </a:prstGeom>
+          <a:noFill/>
+          <a:ln/>
+        </p:spPr>
+        <p:txBody>
+          <a:bodyPr wrap="square" lIns="0" tIns="0" rIns="0" bIns="0" rtlCol="0" anchor="t"/>
+          <a:lstStyle/>
+          <a:p>
+            <a:pPr indent="0" marL="0">
+              <a:buNone/>
+            </a:pPr>
+            <a:r>
+              <a:rPr lang="en-US" sz="1200" spc="100" kern="0" dirty="0">
+                <a:solidFill>
+                  <a:schemeClr val="accent2"/>
+                </a:solidFill>
+                <a:latin typeface="Consolas" pitchFamily="34" charset="0"/>
+                <a:ea typeface="Consolas" pitchFamily="34" charset="-122"/>
+                <a:cs typeface="Consolas" pitchFamily="34" charset="-120"/>
+              </a:rPr>
+              <a:t>02</a:t>
+            </a:r>
+            <a:endParaRPr lang="en-US" sz="1200" dirty="0"/>
+          </a:p>
+        </p:txBody>
+      </p:sp>
+      <p:sp>
+        <p:nvSpPr>
+          <p:cNvPr id="11" name="Text 8"/>
+          <p:cNvSpPr txBox="1"/>
+          <p:nvPr/>
+        </p:nvSpPr>
+        <p:spPr>
+          <a:xfrm>
+            <a:off x="4679950" y="2679700"/>
+            <a:ext cx="2825750" cy="698500"/>
+          </a:xfrm>
+          <a:prstGeom prst="rect">
+            <a:avLst/>
+          </a:prstGeom>
+          <a:noFill/>
+          <a:ln/>
+        </p:spPr>
+        <p:txBody>
+          <a:bodyPr wrap="square" lIns="0" tIns="0" rIns="0" bIns="0" rtlCol="0" anchor="t"/>
+          <a:lstStyle/>
+          <a:p>
+            <a:pPr indent="0" marL="0">
+              <a:buNone/>
+            </a:pPr>
+            <a:r>
+              <a:rPr lang="en-US" sz="2000" b="1" dirty="0">
+                <a:solidFill>
+                  <a:schemeClr val="bg1"/>
+                </a:solidFill>
+              </a:rPr>
+              <a:t>Hands up, someone down</a:t>
+            </a:r>
+            <a:endParaRPr lang="en-US" sz="2000" dirty="0"/>
+          </a:p>
+        </p:txBody>
+      </p:sp>
+      <p:sp>
+        <p:nvSpPr>
+          <p:cNvPr id="12" name="Text 9"/>
+          <p:cNvSpPr txBox="1"/>
+          <p:nvPr/>
+        </p:nvSpPr>
+        <p:spPr>
+          <a:xfrm>
+            <a:off x="4679950" y="3467100"/>
+            <a:ext cx="2825750" cy="1333500"/>
+          </a:xfrm>
+          <a:prstGeom prst="rect">
+            <a:avLst/>
+          </a:prstGeom>
+          <a:noFill/>
+          <a:ln/>
+        </p:spPr>
+        <p:txBody>
+          <a:bodyPr wrap="square" lIns="0" tIns="0" rIns="0" bIns="0" rtlCol="0" anchor="t"/>
+          <a:lstStyle/>
+          <a:p>
+            <a:pPr indent="0" marL="0">
+              <a:buNone/>
+            </a:pPr>
+            <a:r>
+              <a:rPr lang="en-US" sz="1400" dirty="0">
+                <a:solidFill>
+                  <a:schemeClr val="bg2"/>
+                </a:solidFill>
+              </a:rPr>
+              <a:t>Hands raised above the head, and whether they faced the camera. Lying for 10 s, or both hands up for 3 s, can be an alert.</a:t>
+            </a:r>
+            <a:endParaRPr lang="en-US" sz="1400" dirty="0"/>
+          </a:p>
+        </p:txBody>
+      </p:sp>
+      <p:sp>
+        <p:nvSpPr>
+          <p:cNvPr id="13" name="pose-card-03"/>
+          <p:cNvSpPr/>
+          <p:nvPr/>
+        </p:nvSpPr>
+        <p:spPr>
+          <a:xfrm>
+            <a:off x="7988300" y="2095500"/>
+            <a:ext cx="3384550" cy="2794000"/>
+          </a:xfrm>
+          <a:prstGeom prst="roundRect">
+            <a:avLst>
+              <a:gd name="adj" fmla="val 4545"/>
+            </a:avLst>
+          </a:prstGeom>
+          <a:solidFill>
+            <a:schemeClr val="accent3"/>
+          </a:solidFill>
+          <a:ln w="19050">
+            <a:solidFill>
+              <a:schemeClr val="accent1"/>
+            </a:solidFill>
+            <a:prstDash val="solid"/>
+          </a:ln>
+        </p:spPr>
+      </p:sp>
+      <p:sp>
+        <p:nvSpPr>
+          <p:cNvPr id="14" name="Text 11"/>
+          <p:cNvSpPr txBox="1"/>
+          <p:nvPr/>
+        </p:nvSpPr>
+        <p:spPr>
+          <a:xfrm>
+            <a:off x="8267700" y="2374900"/>
+            <a:ext cx="2825750" cy="215900"/>
+          </a:xfrm>
+          <a:prstGeom prst="rect">
+            <a:avLst/>
+          </a:prstGeom>
+          <a:noFill/>
+          <a:ln/>
+        </p:spPr>
+        <p:txBody>
+          <a:bodyPr wrap="square" lIns="0" tIns="0" rIns="0" bIns="0" rtlCol="0" anchor="t"/>
+          <a:lstStyle/>
+          <a:p>
+            <a:pPr indent="0" marL="0">
+              <a:buNone/>
+            </a:pPr>
+            <a:r>
+              <a:rPr lang="en-US" sz="1200" spc="100" kern="0" dirty="0">
+                <a:solidFill>
+                  <a:schemeClr val="accent2"/>
+                </a:solidFill>
+                <a:latin typeface="Consolas" pitchFamily="34" charset="0"/>
+                <a:ea typeface="Consolas" pitchFamily="34" charset="-122"/>
+                <a:cs typeface="Consolas" pitchFamily="34" charset="-120"/>
+              </a:rPr>
+              <a:t>03</a:t>
+            </a:r>
+            <a:endParaRPr lang="en-US" sz="1200" dirty="0"/>
+          </a:p>
+        </p:txBody>
+      </p:sp>
+      <p:sp>
+        <p:nvSpPr>
+          <p:cNvPr id="15" name="Text 12"/>
+          <p:cNvSpPr txBox="1"/>
+          <p:nvPr/>
+        </p:nvSpPr>
+        <p:spPr>
+          <a:xfrm>
+            <a:off x="8267700" y="2679700"/>
+            <a:ext cx="2825750" cy="698500"/>
+          </a:xfrm>
+          <a:prstGeom prst="rect">
+            <a:avLst/>
+          </a:prstGeom>
+          <a:noFill/>
+          <a:ln/>
+        </p:spPr>
+        <p:txBody>
+          <a:bodyPr wrap="square" lIns="0" tIns="0" rIns="0" bIns="0" rtlCol="0" anchor="t"/>
+          <a:lstStyle/>
+          <a:p>
+            <a:pPr indent="0" marL="0">
+              <a:buNone/>
+            </a:pPr>
+            <a:r>
+              <a:rPr lang="en-US" sz="2000" b="1" dirty="0">
+                <a:solidFill>
+                  <a:schemeClr val="bg1"/>
+                </a:solidFill>
+              </a:rPr>
+              <a:t>What they wore</a:t>
+            </a:r>
+            <a:endParaRPr lang="en-US" sz="2000" dirty="0"/>
+          </a:p>
+        </p:txBody>
+      </p:sp>
+      <p:sp>
+        <p:nvSpPr>
+          <p:cNvPr id="16" name="Text 13"/>
+          <p:cNvSpPr txBox="1"/>
+          <p:nvPr/>
+        </p:nvSpPr>
+        <p:spPr>
+          <a:xfrm>
+            <a:off x="8267700" y="3467100"/>
+            <a:ext cx="2825750" cy="1333500"/>
+          </a:xfrm>
+          <a:prstGeom prst="rect">
+            <a:avLst/>
+          </a:prstGeom>
+          <a:noFill/>
+          <a:ln/>
+        </p:spPr>
+        <p:txBody>
+          <a:bodyPr wrap="square" lIns="0" tIns="0" rIns="0" bIns="0" rtlCol="0" anchor="t"/>
+          <a:lstStyle/>
+          <a:p>
+            <a:pPr indent="0" marL="0">
+              <a:buNone/>
+            </a:pPr>
+            <a:r>
+              <a:rPr lang="en-US" sz="1400" dirty="0">
+                <a:solidFill>
+                  <a:srgbClr val="C7D3EA"/>
+                </a:solidFill>
+              </a:rPr>
+              <a:t>The colour of the top and of the trousers, read from the clothes the body outlines. "A red top and blue jeans this morning?"</a:t>
+            </a:r>
+            <a:endParaRPr lang="en-US" sz="1400" dirty="0"/>
+          </a:p>
+        </p:txBody>
+      </p:sp>
+      <p:sp>
+        <p:nvSpPr>
+          <p:cNvPr id="17" name="Text 14"/>
+          <p:cNvSpPr txBox="1"/>
+          <p:nvPr/>
+        </p:nvSpPr>
+        <p:spPr>
+          <a:xfrm>
+            <a:off x="812800" y="5143500"/>
+            <a:ext cx="10566400" cy="571500"/>
+          </a:xfrm>
+          <a:prstGeom prst="rect">
+            <a:avLst/>
+          </a:prstGeom>
+          <a:noFill/>
+          <a:ln/>
+        </p:spPr>
+        <p:txBody>
+          <a:bodyPr wrap="square" lIns="0" tIns="0" rIns="0" bIns="0" rtlCol="0" anchor="t"/>
+          <a:lstStyle/>
+          <a:p>
+            <a:pPr indent="0" marL="0">
+              <a:buNone/>
+            </a:pPr>
+            <a:r>
+              <a:rPr lang="en-US" sz="1400" b="1" dirty="0">
+                <a:solidFill>
+                  <a:schemeClr val="bg1"/>
+                </a:solidFill>
+              </a:rPr>
+              <a:t>How: </a:t>
+            </a:r>
+            <a:pPr indent="0" marL="0">
+              <a:buNone/>
+            </a:pPr>
+            <a:r>
+              <a:rPr lang="en-US" sz="1400" dirty="0">
+                <a:solidFill>
+                  <a:schemeClr val="bg2"/>
+                </a:solidFill>
+              </a:rPr>
+              <a:t>17 body points per person, about once a second, on the same server. Person-down is checked on staged falls at each site before it goes live.</a:t>
+            </a:r>
+            <a:endParaRPr lang="en-US" sz="1400" dirty="0"/>
+          </a:p>
+        </p:txBody>
+      </p:sp>
+      <p:sp>
+        <p:nvSpPr>
+          <p:cNvPr id="25" name="Slide Number Placeholder 0"/>
+          <p:cNvSpPr>
+            <a:spLocks noGrp="1"/>
+          </p:cNvSpPr>
+          <p:nvPr>
+            <p:ph type="sldNum" sz="quarter" idx="4294967295"/>
+          </p:nvPr>
+        </p:nvSpPr>
+        <p:spPr>
+          <a:xfrm>
+            <a:off x="10109200" y="6286500"/>
+            <a:ext cx="1270000" cy="228600"/>
+          </a:xfrm>
+          <a:prstGeom prst="rect">
+            <a:avLst/>
+          </a:prstGeom>
+          <a:extLst>
+            <a:ext uri="{C572A759-6A51-4108-AA02-DFA0A04FC94B}">
+              <ma14:wrappingTextBoxFlag xmlns:ma14="http://schemas.microsoft.com/office/mac/drawingml/2011/main" val="0"/>
+            </a:ext>
+          </a:extLst>
+        </p:spPr>
+        <p:txBody>
+          <a:bodyPr/>
+          <a:lstStyle>
+            <a:lvl1pPr>
+              <a:defRPr sz="1200">
+                <a:solidFill>
+                  <a:srgbClr val="7E8BA6"/>
+                </a:solidFill>
+                <a:latin typeface="Consolas"/>
+                <a:ea typeface="Consolas"/>
+                <a:cs typeface="Consolas"/>
+              </a:defRPr>
+            </a:lvl1pPr>
+          </a:lstStyle>
+          <a:p>
+            <a:pPr algn="r"/>
+            <a:fld id="{F7021451-1387-4CA6-816F-3879F97B5CBC}" type="slidenum">
+              <a:rPr b="0" lang="en-US"/>
+              <a:t>9</a:t>
+            </a:fld>
+            <a:endParaRPr lang="en-US"/>
+          </a:p>
+        </p:txBody>
+      </p:sp>
+    </p:spTree>
+  </p:cSld>
+  <p:clrMapOvr>
+    <a:masterClrMapping/>
+  </p:clrMapOvr>
+</p:sld>
+</file>
+
+<file path=ppt/slides/slide11.xml><?xml version="1.0" encoding="utf-8"?>
+<p:sld xmlns:a="http://schemas.openxmlformats.org/drawingml/2006/main" xmlns:r="http://schemas.openxmlformats.org/officeDocument/2006/relationships" xmlns:p="http://schemas.openxmlformats.org/presentationml/2006/main">
   <p:cSld name="Slide 10">
     <p:spTree>
       <p:nvGrpSpPr>
@@ -4224,7 +4914,7 @@
 </p:sld>
 </file>
 
-<file path=ppt/slides/slide11.xml><?xml version="1.0" encoding="utf-8"?>
+<file path=ppt/slides/slide12.xml><?xml version="1.0" encoding="utf-8"?>
 <p:sld xmlns:a="http://schemas.openxmlformats.org/drawingml/2006/main" xmlns:r="http://schemas.openxmlformats.org/officeDocument/2006/relationships" xmlns:p="http://schemas.openxmlformats.org/presentationml/2006/main">
   <p:cSld name="Slide 11">
     <p:spTree>
@@ -5375,7 +6065,7 @@
 </p:sld>
 </file>
 
-<file path=ppt/slides/slide12.xml><?xml version="1.0" encoding="utf-8"?>
+<file path=ppt/slides/slide13.xml><?xml version="1.0" encoding="utf-8"?>
 <p:sld xmlns:a="http://schemas.openxmlformats.org/drawingml/2006/main" xmlns:r="http://schemas.openxmlformats.org/officeDocument/2006/relationships" xmlns:p="http://schemas.openxmlformats.org/presentationml/2006/main">
   <p:cSld name="Slide 12">
     <p:spTree>
@@ -5929,7 +6619,7 @@
 </p:sld>
 </file>
 
-<file path=ppt/slides/slide13.xml><?xml version="1.0" encoding="utf-8"?>
+<file path=ppt/slides/slide14.xml><?xml version="1.0" encoding="utf-8"?>
 <p:sld xmlns:a="http://schemas.openxmlformats.org/drawingml/2006/main" xmlns:r="http://schemas.openxmlformats.org/officeDocument/2006/relationships" xmlns:p="http://schemas.openxmlformats.org/presentationml/2006/main">
   <p:cSld name="Slide 13">
     <p:spTree>
@@ -6204,6 +6894,24 @@
             </a:r>
             <a:endParaRPr lang="en-US" sz="1400" dirty="0"/>
           </a:p>
+          <a:p>
+            <a:pPr marL="228600" indent="-228600">
+              <a:spcAft>
+                <a:spcPts val="600"/>
+              </a:spcAft>
+              <a:buSzPct val="100000"/>
+              <a:buChar char="•"/>
+            </a:pPr>
+            <a:r>
+              <a:rPr lang="en-US" sz="1400" dirty="0">
+                <a:solidFill>
+                  <a:srgbClr val="C7D3EA"/>
+                </a:solidFill>
+              </a:rPr>
+              <a:t>Body poses: posture, hands up, clothing colours, person-down alerts</a:t>
+            </a:r>
+            <a:endParaRPr lang="en-US" sz="1400" dirty="0"/>
+          </a:p>
         </p:txBody>
       </p:sp>
       <p:sp>
@@ -6375,6 +7083,24 @@
                   <a:schemeClr val="bg2"/>
                 </a:solidFill>
               </a:rPr>
+              <a:t>Person-down checked on staged falls at a pilot site</a:t>
+            </a:r>
+            <a:endParaRPr lang="en-US" sz="1400" dirty="0"/>
+          </a:p>
+          <a:p>
+            <a:pPr marL="228600" indent="-228600">
+              <a:spcAft>
+                <a:spcPts val="600"/>
+              </a:spcAft>
+              <a:buSzPct val="100000"/>
+              <a:buChar char="•"/>
+            </a:pPr>
+            <a:r>
+              <a:rPr lang="en-US" sz="1400" dirty="0">
+                <a:solidFill>
+                  <a:schemeClr val="bg2"/>
+                </a:solidFill>
+              </a:rPr>
               <a:t>Alerts from a description</a:t>
             </a:r>
             <a:endParaRPr lang="en-US" sz="1400" dirty="0"/>
@@ -6437,7 +7163,7 @@
 </p:sld>
 </file>
 
-<file path=ppt/slides/slide14.xml><?xml version="1.0" encoding="utf-8"?>
+<file path=ppt/slides/slide15.xml><?xml version="1.0" encoding="utf-8"?>
 <p:sld xmlns:a="http://schemas.openxmlformats.org/drawingml/2006/main" xmlns:r="http://schemas.openxmlformats.org/officeDocument/2006/relationships" xmlns:p="http://schemas.openxmlformats.org/presentationml/2006/main">
   <p:cSld name="Slide 14">
     <p:spTree>
@@ -10632,6 +11358,212 @@
                   </a:tcPr>
                 </a:tc>
               </a:tr>
+              <a:tr h="635000">
+                <a:tc>
+                  <a:txBody>
+                    <a:bodyPr/>
+                    <a:lstStyle/>
+                    <a:p>
+                      <a:pPr indent="0" marL="0">
+                        <a:buNone/>
+                      </a:pPr>
+                      <a:r>
+                        <a:rPr lang="en-US" sz="1400" dirty="0">
+                          <a:solidFill>
+                            <a:schemeClr val="bg1"/>
+                          </a:solidFill>
+                          <a:latin typeface="Arial" pitchFamily="34" charset="0"/>
+                          <a:ea typeface="Arial" pitchFamily="34" charset="-122"/>
+                          <a:cs typeface="Arial" pitchFamily="34" charset="-120"/>
+                        </a:rPr>
+                        <a:t>Anyone lying on the floor last night?</a:t>
+                      </a:r>
+                      <a:endParaRPr lang="en-US" sz="1400" dirty="0">
+                        <a:latin typeface="Arial" charset="0"/>
+                        <a:ea typeface="Arial" charset="0"/>
+                        <a:cs typeface="Arial" charset="0"/>
+                      </a:endParaRPr>
+                    </a:p>
+                  </a:txBody>
+                  <a:tcPr marL="137160" marR="137160" marT="91440" marB="91440" anchor="ctr">
+                    <a:lnL w="9525" cap="flat" cmpd="sng" algn="ctr">
+                      <a:solidFill>
+                        <a:srgbClr val="22304F"/>
+                      </a:solidFill>
+                      <a:prstDash val="solid"/>
+                      <a:round/>
+                      <a:headEnd type="none" w="med" len="med"/>
+                      <a:tailEnd type="none" w="med" len="med"/>
+                    </a:lnL>
+                    <a:lnR w="9525" cap="flat" cmpd="sng" algn="ctr">
+                      <a:solidFill>
+                        <a:srgbClr val="22304F"/>
+                      </a:solidFill>
+                      <a:prstDash val="solid"/>
+                      <a:round/>
+                      <a:headEnd type="none" w="med" len="med"/>
+                      <a:tailEnd type="none" w="med" len="med"/>
+                    </a:lnR>
+                    <a:lnT w="9525" cap="flat" cmpd="sng" algn="ctr">
+                      <a:solidFill>
+                        <a:srgbClr val="22304F"/>
+                      </a:solidFill>
+                      <a:prstDash val="solid"/>
+                      <a:round/>
+                      <a:headEnd type="none" w="med" len="med"/>
+                      <a:tailEnd type="none" w="med" len="med"/>
+                    </a:lnT>
+                    <a:lnB w="9525" cap="flat" cmpd="sng" algn="ctr">
+                      <a:solidFill>
+                        <a:srgbClr val="22304F"/>
+                      </a:solidFill>
+                      <a:prstDash val="solid"/>
+                      <a:round/>
+                      <a:headEnd type="none" w="med" len="med"/>
+                      <a:tailEnd type="none" w="med" len="med"/>
+                    </a:lnB>
+                    <a:solidFill>
+                      <a:schemeClr val="tx1"/>
+                    </a:solidFill>
+                  </a:tcPr>
+                </a:tc>
+                <a:tc>
+                  <a:txBody>
+                    <a:bodyPr/>
+                    <a:lstStyle/>
+                    <a:p>
+                      <a:pPr indent="0" marL="0">
+                        <a:buNone/>
+                      </a:pPr>
+                      <a:r>
+                        <a:rPr lang="en-US" sz="1400" dirty="0">
+                          <a:solidFill>
+                            <a:schemeClr val="bg2"/>
+                          </a:solidFill>
+                          <a:latin typeface="Arial" pitchFamily="34" charset="0"/>
+                          <a:ea typeface="Arial" pitchFamily="34" charset="-122"/>
+                          <a:cs typeface="Arial" pitchFamily="34" charset="-120"/>
+                        </a:rPr>
+                        <a:t>Each person's posture from body points: seconds standing, sitting or lying</a:t>
+                      </a:r>
+                      <a:endParaRPr lang="en-US" sz="1400" dirty="0">
+                        <a:latin typeface="Arial" charset="0"/>
+                        <a:ea typeface="Arial" charset="0"/>
+                        <a:cs typeface="Arial" charset="0"/>
+                      </a:endParaRPr>
+                    </a:p>
+                  </a:txBody>
+                  <a:tcPr marL="137160" marR="137160" marT="91440" marB="91440" anchor="ctr">
+                    <a:lnL w="9525" cap="flat" cmpd="sng" algn="ctr">
+                      <a:solidFill>
+                        <a:srgbClr val="22304F"/>
+                      </a:solidFill>
+                      <a:prstDash val="solid"/>
+                      <a:round/>
+                      <a:headEnd type="none" w="med" len="med"/>
+                      <a:tailEnd type="none" w="med" len="med"/>
+                    </a:lnL>
+                    <a:lnR w="9525" cap="flat" cmpd="sng" algn="ctr">
+                      <a:solidFill>
+                        <a:srgbClr val="22304F"/>
+                      </a:solidFill>
+                      <a:prstDash val="solid"/>
+                      <a:round/>
+                      <a:headEnd type="none" w="med" len="med"/>
+                      <a:tailEnd type="none" w="med" len="med"/>
+                    </a:lnR>
+                    <a:lnT w="9525" cap="flat" cmpd="sng" algn="ctr">
+                      <a:solidFill>
+                        <a:srgbClr val="22304F"/>
+                      </a:solidFill>
+                      <a:prstDash val="solid"/>
+                      <a:round/>
+                      <a:headEnd type="none" w="med" len="med"/>
+                      <a:tailEnd type="none" w="med" len="med"/>
+                    </a:lnT>
+                    <a:lnB w="9525" cap="flat" cmpd="sng" algn="ctr">
+                      <a:solidFill>
+                        <a:srgbClr val="22304F"/>
+                      </a:solidFill>
+                      <a:prstDash val="solid"/>
+                      <a:round/>
+                      <a:headEnd type="none" w="med" len="med"/>
+                      <a:tailEnd type="none" w="med" len="med"/>
+                    </a:lnB>
+                    <a:solidFill>
+                      <a:schemeClr val="tx1"/>
+                    </a:solidFill>
+                  </a:tcPr>
+                </a:tc>
+                <a:tc>
+                  <a:txBody>
+                    <a:bodyPr/>
+                    <a:lstStyle/>
+                    <a:p>
+                      <a:pPr indent="0" marL="0">
+                        <a:buNone/>
+                      </a:pPr>
+                      <a:r>
+                        <a:rPr lang="en-US" sz="1400" dirty="0">
+                          <a:solidFill>
+                            <a:schemeClr val="bg2"/>
+                          </a:solidFill>
+                          <a:latin typeface="Arial" pitchFamily="34" charset="0"/>
+                          <a:ea typeface="Arial" pitchFamily="34" charset="-122"/>
+                          <a:cs typeface="Arial" pitchFamily="34" charset="-120"/>
+                        </a:rPr>
+                        <a:t>Exact</a:t>
+                      </a:r>
+                      <a:endParaRPr lang="en-US" sz="1400" dirty="0">
+                        <a:latin typeface="Arial" charset="0"/>
+                        <a:ea typeface="Arial" charset="0"/>
+                        <a:cs typeface="Arial" charset="0"/>
+                      </a:endParaRPr>
+                    </a:p>
+                  </a:txBody>
+                  <a:tcPr marL="137160" marR="137160" marT="91440" marB="91440" anchor="ctr">
+                    <a:lnL w="9525" cap="flat" cmpd="sng" algn="ctr">
+                      <a:solidFill>
+                        <a:srgbClr val="22304F"/>
+                      </a:solidFill>
+                      <a:prstDash val="solid"/>
+                      <a:round/>
+                      <a:headEnd type="none" w="med" len="med"/>
+                      <a:tailEnd type="none" w="med" len="med"/>
+                    </a:lnL>
+                    <a:lnR w="9525" cap="flat" cmpd="sng" algn="ctr">
+                      <a:solidFill>
+                        <a:srgbClr val="22304F"/>
+                      </a:solidFill>
+                      <a:prstDash val="solid"/>
+                      <a:round/>
+                      <a:headEnd type="none" w="med" len="med"/>
+                      <a:tailEnd type="none" w="med" len="med"/>
+                    </a:lnR>
+                    <a:lnT w="9525" cap="flat" cmpd="sng" algn="ctr">
+                      <a:solidFill>
+                        <a:srgbClr val="22304F"/>
+                      </a:solidFill>
+                      <a:prstDash val="solid"/>
+                      <a:round/>
+                      <a:headEnd type="none" w="med" len="med"/>
+                      <a:tailEnd type="none" w="med" len="med"/>
+                    </a:lnT>
+                    <a:lnB w="9525" cap="flat" cmpd="sng" algn="ctr">
+                      <a:solidFill>
+                        <a:srgbClr val="22304F"/>
+                      </a:solidFill>
+                      <a:prstDash val="solid"/>
+                      <a:round/>
+                      <a:headEnd type="none" w="med" len="med"/>
+                      <a:tailEnd type="none" w="med" len="med"/>
+                    </a:lnB>
+                    <a:solidFill>
+                      <a:schemeClr val="tx1"/>
+                    </a:solidFill>
+                  </a:tcPr>
+                </a:tc>
+              </a:tr>
             </a:tbl>
           </a:graphicData>
         </a:graphic>

</xml_diff>